<commit_message>
Give every deployed deck a unique background architecture: add 4 new layouts (lspine, tint, corner, blocktitle); move Vishvaksen->tint, Hrishikesh->lspine, Nemi->blocktitle, Kasireddy->corner so no two of the 12 deployed decks share a content archetype
</commit_message>
<xml_diff>
--- a/ppt/X24303046_ev-charging-network.pptx
+++ b/ppt/X24303046_ev-charging-network.pptx
@@ -3342,200 +3342,16 @@
       <p:grpSpPr/>
       <p:sp>
         <p:nvSpPr>
-          <p:cNvPr id="2" name="Title 1"/>
-          <p:cNvSpPr>
-            <a:spLocks noGrp="1"/>
-          </p:cNvSpPr>
-          <p:nvPr>
-            <p:ph type="title"/>
-          </p:nvPr>
+          <p:cNvPr id="4" name="Rounded Rectangle 3"/>
+          <p:cNvSpPr/>
+          <p:nvPr/>
         </p:nvSpPr>
         <p:spPr>
           <a:xfrm>
             <a:off x="640080" y="457200"/>
-            <a:ext cx="9311335" cy="868680"/>
+            <a:ext cx="5961888" cy="841248"/>
           </a:xfrm>
-        </p:spPr>
-        <p:txBody>
-          <a:bodyPr wrap="square" anchor="t"/>
-          <a:lstStyle/>
-          <a:p>
-            <a:pPr algn="l"/>
-            <a:r>
-              <a:rPr b="1" sz="2400">
-                <a:solidFill>
-                  <a:srgbClr val="17924F"/>
-                </a:solidFill>
-                <a:latin typeface="Corbel"/>
-              </a:rPr>
-              <a:t>Why periodic checks fail at a charging hub</a:t>
-            </a:r>
-          </a:p>
-        </p:txBody>
-      </p:sp>
-      <p:sp>
-        <p:nvSpPr>
-          <p:cNvPr id="3" name="Content Placeholder 2"/>
-          <p:cNvSpPr>
-            <a:spLocks noGrp="1"/>
-          </p:cNvSpPr>
-          <p:nvPr>
-            <p:ph idx="1"/>
-          </p:nvPr>
-        </p:nvSpPr>
-        <p:spPr>
-          <a:xfrm>
-            <a:off x="658368" y="1508760"/>
-            <a:ext cx="9402775" cy="4846320"/>
-          </a:xfrm>
-        </p:spPr>
-        <p:txBody>
-          <a:bodyPr wrap="square">
-            <a:normAutofit/>
-          </a:bodyPr>
-          <a:lstStyle/>
-          <a:p>
-            <a:pPr>
-              <a:spcAft>
-                <a:spcPts val="600"/>
-              </a:spcAft>
-            </a:pPr>
-            <a:r>
-              <a:rPr sz="1500" b="0">
-                <a:solidFill>
-                  <a:srgbClr val="232A26"/>
-                </a:solidFill>
-                <a:latin typeface="Calibri"/>
-              </a:rPr>
-              <a:t>Conditions move in seconds: ten sensors across two charging hubs sample current, battery charge, temperature, grid load and session time every 2 to 5 seconds.</a:t>
-            </a:r>
-          </a:p>
-          <a:p>
-            <a:pPr>
-              <a:spcAft>
-                <a:spcPts val="600"/>
-              </a:spcAft>
-            </a:pPr>
-            <a:r>
-              <a:rPr sz="1500" b="0">
-                <a:solidFill>
-                  <a:srgbClr val="232A26"/>
-                </a:solidFill>
-                <a:latin typeface="Calibri"/>
-              </a:rPr>
-              <a:t>A manual round or an hourly poll leaves an overloaded or overheating bay unnoticed for the whole gap between checks.</a:t>
-            </a:r>
-          </a:p>
-          <a:p>
-            <a:pPr>
-              <a:spcAft>
-                <a:spcPts val="600"/>
-              </a:spcAft>
-            </a:pPr>
-            <a:r>
-              <a:rPr sz="1500" b="0">
-                <a:solidFill>
-                  <a:srgbClr val="232A26"/>
-                </a:solidFill>
-                <a:latin typeface="Calibri"/>
-              </a:rPr>
-              <a:t>Streaming every raw reading to the cloud is the wasteful alternative; the decision has to happen close to the hardware.</a:t>
-            </a:r>
-          </a:p>
-          <a:p>
-            <a:pPr>
-              <a:spcAft>
-                <a:spcPts val="600"/>
-              </a:spcAft>
-            </a:pPr>
-            <a:r>
-              <a:rPr sz="1500" b="1">
-                <a:solidFill>
-                  <a:srgbClr val="17924F"/>
-                </a:solidFill>
-                <a:latin typeface="Calibri"/>
-              </a:rPr>
-              <a:t>The fog node's four live alert rules:</a:t>
-            </a:r>
-          </a:p>
-          <a:p>
-            <a:pPr lvl="1">
-              <a:spcAft>
-                <a:spcPts val="600"/>
-              </a:spcAft>
-            </a:pPr>
-            <a:r>
-              <a:rPr sz="1300" b="0">
-                <a:solidFill>
-                  <a:srgbClr val="232A26"/>
-                </a:solidFill>
-                <a:latin typeface="Calibri"/>
-              </a:rPr>
-              <a:t>Average charging current above 32 A flags overcurrent.</a:t>
-            </a:r>
-          </a:p>
-          <a:p>
-            <a:pPr lvl="1">
-              <a:spcAft>
-                <a:spcPts val="600"/>
-              </a:spcAft>
-            </a:pPr>
-            <a:r>
-              <a:rPr sz="1300" b="0">
-                <a:solidFill>
-                  <a:srgbClr val="232A26"/>
-                </a:solidFill>
-                <a:latin typeface="Calibri"/>
-              </a:rPr>
-              <a:t>Station temperature above 45 C flags overheat risk.</a:t>
-            </a:r>
-          </a:p>
-          <a:p>
-            <a:pPr lvl="1">
-              <a:spcAft>
-                <a:spcPts val="600"/>
-              </a:spcAft>
-            </a:pPr>
-            <a:r>
-              <a:rPr sz="1300" b="0">
-                <a:solidFill>
-                  <a:srgbClr val="232A26"/>
-                </a:solidFill>
-                <a:latin typeface="Calibri"/>
-              </a:rPr>
-              <a:t>Grid draw above 80 kW flags grid strain.</a:t>
-            </a:r>
-          </a:p>
-          <a:p>
-            <a:pPr lvl="1">
-              <a:spcAft>
-                <a:spcPts val="600"/>
-              </a:spcAft>
-            </a:pPr>
-            <a:r>
-              <a:rPr sz="1300" b="0">
-                <a:solidFill>
-                  <a:srgbClr val="232A26"/>
-                </a:solidFill>
-                <a:latin typeface="Calibri"/>
-              </a:rPr>
-              <a:t>Session length above 180 min flags a stalled session.</a:t>
-            </a:r>
-          </a:p>
-        </p:txBody>
-      </p:sp>
-      <p:sp>
-        <p:nvSpPr>
-          <p:cNvPr id="4" name="Rectangle 3"/>
-          <p:cNvSpPr/>
-          <p:nvPr/>
-        </p:nvSpPr>
-        <p:spPr>
-          <a:xfrm>
-            <a:off x="11140135" y="0"/>
-            <a:ext cx="1051560" cy="6858000"/>
-          </a:xfrm>
-          <a:prstGeom prst="rect">
+          <a:prstGeom prst="roundRect">
             <a:avLst/>
           </a:prstGeom>
           <a:solidFill>
@@ -3570,51 +3386,218 @@
       </p:sp>
       <p:sp>
         <p:nvSpPr>
-          <p:cNvPr id="5" name="TextBox 4"/>
-          <p:cNvSpPr txBox="1"/>
-          <p:nvPr/>
+          <p:cNvPr id="2" name="Title 1"/>
+          <p:cNvSpPr>
+            <a:spLocks noGrp="1"/>
+          </p:cNvSpPr>
+          <p:nvPr>
+            <p:ph type="title"/>
+          </p:nvPr>
         </p:nvSpPr>
         <p:spPr>
           <a:xfrm>
-            <a:off x="11140135" y="320040"/>
-            <a:ext cx="1051560" cy="914400"/>
+            <a:off x="896112" y="457200"/>
+            <a:ext cx="5504688" cy="841248"/>
           </a:xfrm>
-          <a:prstGeom prst="rect">
-            <a:avLst/>
-          </a:prstGeom>
-          <a:noFill/>
         </p:spPr>
         <p:txBody>
-          <a:bodyPr wrap="square" anchor="t">
-            <a:spAutoFit/>
-          </a:bodyPr>
-          <a:lstStyle/>
-          <a:p>
-            <a:pPr algn="ctr"/>
-            <a:r>
-              <a:rPr sz="2600" b="1" i="0">
+          <a:bodyPr wrap="square" anchor="ctr"/>
+          <a:lstStyle/>
+          <a:p>
+            <a:pPr algn="l"/>
+            <a:r>
+              <a:rPr b="1" sz="1900">
                 <a:solidFill>
                   <a:srgbClr val="FFFFFF"/>
                 </a:solidFill>
                 <a:latin typeface="Corbel"/>
               </a:rPr>
-              <a:t>1</a:t>
-            </a:r>
-          </a:p>
-        </p:txBody>
-      </p:sp>
-      <p:sp>
-        <p:nvSpPr>
-          <p:cNvPr id="6" name="Rectangle 5"/>
+              <a:t>Why periodic checks fail at a charging hub</a:t>
+            </a:r>
+          </a:p>
+        </p:txBody>
+      </p:sp>
+      <p:sp>
+        <p:nvSpPr>
+          <p:cNvPr id="3" name="Content Placeholder 2"/>
+          <p:cNvSpPr>
+            <a:spLocks noGrp="1"/>
+          </p:cNvSpPr>
+          <p:nvPr>
+            <p:ph idx="1"/>
+          </p:nvPr>
+        </p:nvSpPr>
+        <p:spPr>
+          <a:xfrm>
+            <a:off x="658368" y="1600200"/>
+            <a:ext cx="10972800" cy="4663440"/>
+          </a:xfrm>
+        </p:spPr>
+        <p:txBody>
+          <a:bodyPr wrap="square">
+            <a:normAutofit/>
+          </a:bodyPr>
+          <a:lstStyle/>
+          <a:p>
+            <a:pPr>
+              <a:spcAft>
+                <a:spcPts val="600"/>
+              </a:spcAft>
+            </a:pPr>
+            <a:r>
+              <a:rPr sz="1500" b="0">
+                <a:solidFill>
+                  <a:srgbClr val="232A26"/>
+                </a:solidFill>
+                <a:latin typeface="Calibri"/>
+              </a:rPr>
+              <a:t>Conditions move in seconds: ten sensors across two charging hubs sample current, battery charge, temperature, grid load and session time every 2 to 5 seconds.</a:t>
+            </a:r>
+          </a:p>
+          <a:p>
+            <a:pPr>
+              <a:spcAft>
+                <a:spcPts val="600"/>
+              </a:spcAft>
+            </a:pPr>
+            <a:r>
+              <a:rPr sz="1500" b="0">
+                <a:solidFill>
+                  <a:srgbClr val="232A26"/>
+                </a:solidFill>
+                <a:latin typeface="Calibri"/>
+              </a:rPr>
+              <a:t>A manual round or an hourly poll leaves an overloaded or overheating bay unnoticed for the whole gap between checks.</a:t>
+            </a:r>
+          </a:p>
+          <a:p>
+            <a:pPr>
+              <a:spcAft>
+                <a:spcPts val="600"/>
+              </a:spcAft>
+            </a:pPr>
+            <a:r>
+              <a:rPr sz="1500" b="0">
+                <a:solidFill>
+                  <a:srgbClr val="232A26"/>
+                </a:solidFill>
+                <a:latin typeface="Calibri"/>
+              </a:rPr>
+              <a:t>Streaming every raw reading to the cloud is the wasteful alternative; the decision has to happen close to the hardware.</a:t>
+            </a:r>
+          </a:p>
+          <a:p>
+            <a:pPr>
+              <a:spcAft>
+                <a:spcPts val="600"/>
+              </a:spcAft>
+            </a:pPr>
+            <a:r>
+              <a:rPr sz="1500" b="1">
+                <a:solidFill>
+                  <a:srgbClr val="17924F"/>
+                </a:solidFill>
+                <a:latin typeface="Calibri"/>
+              </a:rPr>
+              <a:t>The fog node's four live alert rules:</a:t>
+            </a:r>
+          </a:p>
+          <a:p>
+            <a:pPr lvl="1">
+              <a:spcAft>
+                <a:spcPts val="600"/>
+              </a:spcAft>
+            </a:pPr>
+            <a:r>
+              <a:rPr sz="1300" b="0">
+                <a:solidFill>
+                  <a:srgbClr val="232A26"/>
+                </a:solidFill>
+                <a:latin typeface="Calibri"/>
+              </a:rPr>
+              <a:t>Average charging current above 32 A flags overcurrent.</a:t>
+            </a:r>
+          </a:p>
+          <a:p>
+            <a:pPr lvl="1">
+              <a:spcAft>
+                <a:spcPts val="600"/>
+              </a:spcAft>
+            </a:pPr>
+            <a:r>
+              <a:rPr sz="1300" b="0">
+                <a:solidFill>
+                  <a:srgbClr val="232A26"/>
+                </a:solidFill>
+                <a:latin typeface="Calibri"/>
+              </a:rPr>
+              <a:t>Station temperature above 45 C flags overheat risk.</a:t>
+            </a:r>
+          </a:p>
+          <a:p>
+            <a:pPr lvl="1">
+              <a:spcAft>
+                <a:spcPts val="600"/>
+              </a:spcAft>
+            </a:pPr>
+            <a:r>
+              <a:rPr sz="1300" b="0">
+                <a:solidFill>
+                  <a:srgbClr val="232A26"/>
+                </a:solidFill>
+                <a:latin typeface="Calibri"/>
+              </a:rPr>
+              <a:t>Grid draw above 80 kW flags grid strain.</a:t>
+            </a:r>
+          </a:p>
+          <a:p>
+            <a:pPr lvl="1">
+              <a:spcAft>
+                <a:spcPts val="600"/>
+              </a:spcAft>
+            </a:pPr>
+            <a:r>
+              <a:rPr sz="1300" b="0">
+                <a:solidFill>
+                  <a:srgbClr val="232A26"/>
+                </a:solidFill>
+                <a:latin typeface="Calibri"/>
+              </a:rPr>
+              <a:t>Session length above 180 min flags a stalled session.</a:t>
+            </a:r>
+          </a:p>
+        </p:txBody>
+      </p:sp>
+    </p:spTree>
+  </p:cSld>
+  <p:clrMapOvr>
+    <a:masterClrMapping/>
+  </p:clrMapOvr>
+</p:sld>
+</file>
+
+<file path=ppt/slides/slide3.xml><?xml version="1.0" encoding="utf-8"?>
+<p:sld xmlns:a="http://schemas.openxmlformats.org/drawingml/2006/main" xmlns:p="http://schemas.openxmlformats.org/presentationml/2006/main" xmlns:r="http://schemas.openxmlformats.org/officeDocument/2006/relationships">
+  <p:cSld>
+    <p:spTree>
+      <p:nvGrpSpPr>
+        <p:cNvPr id="1" name=""/>
+        <p:cNvGrpSpPr/>
+        <p:nvPr/>
+      </p:nvGrpSpPr>
+      <p:grpSpPr/>
+      <p:sp>
+        <p:nvSpPr>
+          <p:cNvPr id="4" name="Rounded Rectangle 3"/>
           <p:cNvSpPr/>
           <p:nvPr/>
         </p:nvSpPr>
         <p:spPr>
           <a:xfrm>
-            <a:off x="658368" y="1325880"/>
-            <a:ext cx="2926080" cy="36576"/>
+            <a:off x="640080" y="457200"/>
+            <a:ext cx="7196328" cy="841248"/>
           </a:xfrm>
-          <a:prstGeom prst="rect">
+          <a:prstGeom prst="roundRect">
             <a:avLst/>
           </a:prstGeom>
           <a:solidFill>
@@ -3647,6 +3630,182 @@
           </a:p>
         </p:txBody>
       </p:sp>
+      <p:sp>
+        <p:nvSpPr>
+          <p:cNvPr id="2" name="Title 1"/>
+          <p:cNvSpPr>
+            <a:spLocks noGrp="1"/>
+          </p:cNvSpPr>
+          <p:nvPr>
+            <p:ph type="title"/>
+          </p:nvPr>
+        </p:nvSpPr>
+        <p:spPr>
+          <a:xfrm>
+            <a:off x="896112" y="457200"/>
+            <a:ext cx="6739128" cy="841248"/>
+          </a:xfrm>
+        </p:spPr>
+        <p:txBody>
+          <a:bodyPr wrap="square" anchor="ctr"/>
+          <a:lstStyle/>
+          <a:p>
+            <a:pPr algn="l"/>
+            <a:r>
+              <a:rPr b="1" sz="1900">
+                <a:solidFill>
+                  <a:srgbClr val="FFFFFF"/>
+                </a:solidFill>
+                <a:latin typeface="Corbel"/>
+              </a:rPr>
+              <a:t>How it works: decide at the edge, scale in the cloud</a:t>
+            </a:r>
+          </a:p>
+        </p:txBody>
+      </p:sp>
+      <p:sp>
+        <p:nvSpPr>
+          <p:cNvPr id="3" name="Content Placeholder 2"/>
+          <p:cNvSpPr>
+            <a:spLocks noGrp="1"/>
+          </p:cNvSpPr>
+          <p:nvPr>
+            <p:ph idx="1"/>
+          </p:nvPr>
+        </p:nvSpPr>
+        <p:spPr>
+          <a:xfrm>
+            <a:off x="658368" y="1600200"/>
+            <a:ext cx="5760720" cy="4617720"/>
+          </a:xfrm>
+        </p:spPr>
+        <p:txBody>
+          <a:bodyPr wrap="square">
+            <a:normAutofit/>
+          </a:bodyPr>
+          <a:lstStyle/>
+          <a:p>
+            <a:pPr>
+              <a:spcAft>
+                <a:spcPts val="800"/>
+              </a:spcAft>
+            </a:pPr>
+            <a:r>
+              <a:rPr sz="1500" b="1">
+                <a:solidFill>
+                  <a:srgbClr val="17924F"/>
+                </a:solidFill>
+                <a:latin typeface="Calibri"/>
+              </a:rPr>
+              <a:t>At the edge:</a:t>
+            </a:r>
+          </a:p>
+          <a:p>
+            <a:pPr lvl="1">
+              <a:spcAft>
+                <a:spcPts val="800"/>
+              </a:spcAft>
+            </a:pPr>
+            <a:r>
+              <a:rPr sz="1300" b="0">
+                <a:solidFill>
+                  <a:srgbClr val="232A26"/>
+                </a:solidFill>
+                <a:latin typeface="Calibri"/>
+              </a:rPr>
+              <a:t>10 sensors across 2 hubs, 5 metrics each, feed a fog node that windows, aggregates and alerts.</a:t>
+            </a:r>
+          </a:p>
+          <a:p>
+            <a:pPr lvl="1">
+              <a:spcAft>
+                <a:spcPts val="800"/>
+              </a:spcAft>
+            </a:pPr>
+            <a:r>
+              <a:rPr sz="1300" b="0">
+                <a:solidFill>
+                  <a:srgbClr val="232A26"/>
+                </a:solidFill>
+                <a:latin typeface="Calibri"/>
+              </a:rPr>
+              <a:t>Raw readings stay at the edge: the fog node sends one aggregate per sensor per window, so alerts fire next to the hardware.</a:t>
+            </a:r>
+          </a:p>
+          <a:p>
+            <a:pPr>
+              <a:spcAft>
+                <a:spcPts val="800"/>
+              </a:spcAft>
+            </a:pPr>
+            <a:r>
+              <a:rPr sz="1500" b="1">
+                <a:solidFill>
+                  <a:srgbClr val="17924F"/>
+                </a:solidFill>
+                <a:latin typeface="Calibri"/>
+              </a:rPr>
+              <a:t>In the cloud, serverless end to end:</a:t>
+            </a:r>
+          </a:p>
+          <a:p>
+            <a:pPr lvl="1">
+              <a:spcAft>
+                <a:spcPts val="800"/>
+              </a:spcAft>
+            </a:pPr>
+            <a:r>
+              <a:rPr sz="1300" b="0">
+                <a:solidFill>
+                  <a:srgbClr val="232A26"/>
+                </a:solidFill>
+                <a:latin typeface="Calibri"/>
+              </a:rPr>
+              <a:t>Amazon SQS carries each window summary, an AWS Lambda ingests it, Amazon DynamoDB is the durable store, and API Gateway with an S3 static site serves the dashboard.</a:t>
+            </a:r>
+          </a:p>
+          <a:p>
+            <a:pPr lvl="1">
+              <a:spcAft>
+                <a:spcPts val="800"/>
+              </a:spcAft>
+            </a:pPr>
+            <a:r>
+              <a:rPr sz="1300" b="0">
+                <a:solidFill>
+                  <a:srgbClr val="232A26"/>
+                </a:solidFill>
+                <a:latin typeface="Calibri"/>
+              </a:rPr>
+              <a:t>Deployed live on a real AWS account through one infrastructure-as-code apply, not only a local emulator.</a:t>
+            </a:r>
+          </a:p>
+        </p:txBody>
+      </p:sp>
+      <p:pic>
+        <p:nvPicPr>
+          <p:cNvPr id="5" name="Picture 4" descr="topology.png"/>
+          <p:cNvPicPr>
+            <a:picLocks noChangeAspect="1"/>
+          </p:cNvPicPr>
+          <p:nvPr/>
+        </p:nvPicPr>
+        <p:blipFill>
+          <a:blip r:embed="rId2"/>
+          <a:stretch>
+            <a:fillRect/>
+          </a:stretch>
+        </p:blipFill>
+        <p:spPr>
+          <a:xfrm>
+            <a:off x="6629400" y="2211520"/>
+            <a:ext cx="5120640" cy="3303638"/>
+          </a:xfrm>
+          <a:prstGeom prst="rect">
+            <a:avLst/>
+          </a:prstGeom>
+        </p:spPr>
+      </p:pic>
     </p:spTree>
   </p:cSld>
   <p:clrMapOvr>
@@ -3655,7 +3814,7 @@
 </p:sld>
 </file>
 
-<file path=ppt/slides/slide3.xml><?xml version="1.0" encoding="utf-8"?>
+<file path=ppt/slides/slide4.xml><?xml version="1.0" encoding="utf-8"?>
 <p:sld xmlns:a="http://schemas.openxmlformats.org/drawingml/2006/main" xmlns:p="http://schemas.openxmlformats.org/presentationml/2006/main" xmlns:r="http://schemas.openxmlformats.org/officeDocument/2006/relationships">
   <p:cSld>
     <p:spTree>
@@ -3667,168 +3826,16 @@
       <p:grpSpPr/>
       <p:sp>
         <p:nvSpPr>
-          <p:cNvPr id="2" name="Title 1"/>
-          <p:cNvSpPr>
-            <a:spLocks noGrp="1"/>
-          </p:cNvSpPr>
-          <p:nvPr>
-            <p:ph type="title"/>
-          </p:nvPr>
+          <p:cNvPr id="4" name="Rounded Rectangle 3"/>
+          <p:cNvSpPr/>
+          <p:nvPr/>
         </p:nvSpPr>
         <p:spPr>
           <a:xfrm>
             <a:off x="640080" y="457200"/>
-            <a:ext cx="9311335" cy="868680"/>
+            <a:ext cx="5344668" cy="841248"/>
           </a:xfrm>
-        </p:spPr>
-        <p:txBody>
-          <a:bodyPr wrap="square" anchor="t"/>
-          <a:lstStyle/>
-          <a:p>
-            <a:pPr algn="l"/>
-            <a:r>
-              <a:rPr b="1" sz="2400">
-                <a:solidFill>
-                  <a:srgbClr val="17924F"/>
-                </a:solidFill>
-                <a:latin typeface="Corbel"/>
-              </a:rPr>
-              <a:t>How it works: decide at the edge, scale in the cloud</a:t>
-            </a:r>
-          </a:p>
-        </p:txBody>
-      </p:sp>
-      <p:sp>
-        <p:nvSpPr>
-          <p:cNvPr id="3" name="Content Placeholder 2"/>
-          <p:cNvSpPr>
-            <a:spLocks noGrp="1"/>
-          </p:cNvSpPr>
-          <p:nvPr>
-            <p:ph idx="1"/>
-          </p:nvPr>
-        </p:nvSpPr>
-        <p:spPr>
-          <a:xfrm>
-            <a:off x="658368" y="1508760"/>
-            <a:ext cx="5577840" cy="4754880"/>
-          </a:xfrm>
-        </p:spPr>
-        <p:txBody>
-          <a:bodyPr wrap="square">
-            <a:normAutofit/>
-          </a:bodyPr>
-          <a:lstStyle/>
-          <a:p>
-            <a:pPr>
-              <a:spcAft>
-                <a:spcPts val="800"/>
-              </a:spcAft>
-            </a:pPr>
-            <a:r>
-              <a:rPr sz="1500" b="1">
-                <a:solidFill>
-                  <a:srgbClr val="17924F"/>
-                </a:solidFill>
-                <a:latin typeface="Calibri"/>
-              </a:rPr>
-              <a:t>At the edge:</a:t>
-            </a:r>
-          </a:p>
-          <a:p>
-            <a:pPr lvl="1">
-              <a:spcAft>
-                <a:spcPts val="800"/>
-              </a:spcAft>
-            </a:pPr>
-            <a:r>
-              <a:rPr sz="1300" b="0">
-                <a:solidFill>
-                  <a:srgbClr val="232A26"/>
-                </a:solidFill>
-                <a:latin typeface="Calibri"/>
-              </a:rPr>
-              <a:t>10 sensors across 2 hubs, 5 metrics each, feed a fog node that windows, aggregates and alerts.</a:t>
-            </a:r>
-          </a:p>
-          <a:p>
-            <a:pPr lvl="1">
-              <a:spcAft>
-                <a:spcPts val="800"/>
-              </a:spcAft>
-            </a:pPr>
-            <a:r>
-              <a:rPr sz="1300" b="0">
-                <a:solidFill>
-                  <a:srgbClr val="232A26"/>
-                </a:solidFill>
-                <a:latin typeface="Calibri"/>
-              </a:rPr>
-              <a:t>Raw readings stay at the edge: the fog node sends one aggregate per sensor per window, so alerts fire next to the hardware.</a:t>
-            </a:r>
-          </a:p>
-          <a:p>
-            <a:pPr>
-              <a:spcAft>
-                <a:spcPts val="800"/>
-              </a:spcAft>
-            </a:pPr>
-            <a:r>
-              <a:rPr sz="1500" b="1">
-                <a:solidFill>
-                  <a:srgbClr val="17924F"/>
-                </a:solidFill>
-                <a:latin typeface="Calibri"/>
-              </a:rPr>
-              <a:t>In the cloud, serverless end to end:</a:t>
-            </a:r>
-          </a:p>
-          <a:p>
-            <a:pPr lvl="1">
-              <a:spcAft>
-                <a:spcPts val="800"/>
-              </a:spcAft>
-            </a:pPr>
-            <a:r>
-              <a:rPr sz="1300" b="0">
-                <a:solidFill>
-                  <a:srgbClr val="232A26"/>
-                </a:solidFill>
-                <a:latin typeface="Calibri"/>
-              </a:rPr>
-              <a:t>Amazon SQS carries each window summary, an AWS Lambda ingests it, Amazon DynamoDB is the durable store, and API Gateway with an S3 static site serves the dashboard.</a:t>
-            </a:r>
-          </a:p>
-          <a:p>
-            <a:pPr lvl="1">
-              <a:spcAft>
-                <a:spcPts val="800"/>
-              </a:spcAft>
-            </a:pPr>
-            <a:r>
-              <a:rPr sz="1300" b="0">
-                <a:solidFill>
-                  <a:srgbClr val="232A26"/>
-                </a:solidFill>
-                <a:latin typeface="Calibri"/>
-              </a:rPr>
-              <a:t>Deployed live on a real AWS account through one infrastructure-as-code apply, not only a local emulator.</a:t>
-            </a:r>
-          </a:p>
-        </p:txBody>
-      </p:sp>
-      <p:sp>
-        <p:nvSpPr>
-          <p:cNvPr id="4" name="Rectangle 3"/>
-          <p:cNvSpPr/>
-          <p:nvPr/>
-        </p:nvSpPr>
-        <p:spPr>
-          <a:xfrm>
-            <a:off x="11140135" y="0"/>
-            <a:ext cx="1051560" cy="6858000"/>
-          </a:xfrm>
-          <a:prstGeom prst="rect">
+          <a:prstGeom prst="roundRect">
             <a:avLst/>
           </a:prstGeom>
           <a:solidFill>
@@ -3863,51 +3870,194 @@
       </p:sp>
       <p:sp>
         <p:nvSpPr>
-          <p:cNvPr id="5" name="TextBox 4"/>
-          <p:cNvSpPr txBox="1"/>
-          <p:nvPr/>
+          <p:cNvPr id="2" name="Title 1"/>
+          <p:cNvSpPr>
+            <a:spLocks noGrp="1"/>
+          </p:cNvSpPr>
+          <p:nvPr>
+            <p:ph type="title"/>
+          </p:nvPr>
         </p:nvSpPr>
         <p:spPr>
           <a:xfrm>
-            <a:off x="11140135" y="320040"/>
-            <a:ext cx="1051560" cy="914400"/>
+            <a:off x="896112" y="457200"/>
+            <a:ext cx="4887468" cy="841248"/>
+          </a:xfrm>
+        </p:spPr>
+        <p:txBody>
+          <a:bodyPr wrap="square" anchor="ctr"/>
+          <a:lstStyle/>
+          <a:p>
+            <a:pPr algn="l"/>
+            <a:r>
+              <a:rPr b="1" sz="2200">
+                <a:solidFill>
+                  <a:srgbClr val="FFFFFF"/>
+                </a:solidFill>
+                <a:latin typeface="Corbel"/>
+              </a:rPr>
+              <a:t>Live on AWS: demonstration highlights</a:t>
+            </a:r>
+          </a:p>
+        </p:txBody>
+      </p:sp>
+      <p:sp>
+        <p:nvSpPr>
+          <p:cNvPr id="3" name="Content Placeholder 2"/>
+          <p:cNvSpPr>
+            <a:spLocks noGrp="1"/>
+          </p:cNvSpPr>
+          <p:nvPr>
+            <p:ph idx="1"/>
+          </p:nvPr>
+        </p:nvSpPr>
+        <p:spPr>
+          <a:xfrm>
+            <a:off x="658368" y="1600200"/>
+            <a:ext cx="5760720" cy="4617720"/>
+          </a:xfrm>
+        </p:spPr>
+        <p:txBody>
+          <a:bodyPr wrap="square">
+            <a:normAutofit/>
+          </a:bodyPr>
+          <a:lstStyle/>
+          <a:p>
+            <a:pPr>
+              <a:spcAft>
+                <a:spcPts val="800"/>
+              </a:spcAft>
+            </a:pPr>
+            <a:r>
+              <a:rPr sz="1500" b="0">
+                <a:solidFill>
+                  <a:srgbClr val="232A26"/>
+                </a:solidFill>
+                <a:latin typeface="Calibri"/>
+              </a:rPr>
+              <a:t>The deployed dashboard, served from Amazon S3 and calling the API through Amazon API Gateway.</a:t>
+            </a:r>
+          </a:p>
+          <a:p>
+            <a:pPr>
+              <a:spcAft>
+                <a:spcPts val="800"/>
+              </a:spcAft>
+            </a:pPr>
+            <a:r>
+              <a:rPr sz="1500" b="0">
+                <a:solidFill>
+                  <a:srgbClr val="232A26"/>
+                </a:solidFill>
+                <a:latin typeface="Calibri"/>
+              </a:rPr>
+              <a:t>Four of four pipeline health checks green on the live account, with the freshest reading a few seconds old.</a:t>
+            </a:r>
+          </a:p>
+          <a:p>
+            <a:pPr>
+              <a:spcAft>
+                <a:spcPts val="800"/>
+              </a:spcAft>
+            </a:pPr>
+            <a:r>
+              <a:rPr sz="1500" b="0">
+                <a:solidFill>
+                  <a:srgbClr val="232A26"/>
+                </a:solidFill>
+                <a:latin typeface="Calibri"/>
+              </a:rPr>
+              <a:t>121 automated tests pass across the sensor, fog, processor and dashboard modules.</a:t>
+            </a:r>
+          </a:p>
+          <a:p>
+            <a:pPr>
+              <a:spcAft>
+                <a:spcPts val="800"/>
+              </a:spcAft>
+            </a:pPr>
+            <a:r>
+              <a:rPr sz="1500" b="0">
+                <a:solidFill>
+                  <a:srgbClr val="232A26"/>
+                </a:solidFill>
+                <a:latin typeface="Calibri"/>
+              </a:rPr>
+              <a:t>Stored records climbed from 26 to 289 across the verification window, confirming genuinely live data.</a:t>
+            </a:r>
+          </a:p>
+          <a:p>
+            <a:pPr>
+              <a:spcAft>
+                <a:spcPts val="800"/>
+              </a:spcAft>
+            </a:pPr>
+            <a:r>
+              <a:rPr sz="1500" b="1">
+                <a:solidFill>
+                  <a:srgbClr val="17924F"/>
+                </a:solidFill>
+                <a:latin typeface="Calibri"/>
+              </a:rPr>
+              <a:t>Two safety alerts firing live on hub-1: overheat risk and grid strain, both raised at the fog node.</a:t>
+            </a:r>
+          </a:p>
+        </p:txBody>
+      </p:sp>
+      <p:pic>
+        <p:nvPicPr>
+          <p:cNvPr id="5" name="Picture 4" descr="dashboard.png"/>
+          <p:cNvPicPr>
+            <a:picLocks noChangeAspect="1"/>
+          </p:cNvPicPr>
+          <p:nvPr/>
+        </p:nvPicPr>
+        <p:blipFill>
+          <a:blip r:embed="rId2"/>
+          <a:stretch>
+            <a:fillRect/>
+          </a:stretch>
+        </p:blipFill>
+        <p:spPr>
+          <a:xfrm>
+            <a:off x="6629400" y="1705356"/>
+            <a:ext cx="5120640" cy="4315968"/>
           </a:xfrm>
           <a:prstGeom prst="rect">
             <a:avLst/>
           </a:prstGeom>
-          <a:noFill/>
         </p:spPr>
-        <p:txBody>
-          <a:bodyPr wrap="square" anchor="t">
-            <a:spAutoFit/>
-          </a:bodyPr>
-          <a:lstStyle/>
-          <a:p>
-            <a:pPr algn="ctr"/>
-            <a:r>
-              <a:rPr sz="2600" b="1" i="0">
-                <a:solidFill>
-                  <a:srgbClr val="FFFFFF"/>
-                </a:solidFill>
-                <a:latin typeface="Corbel"/>
-              </a:rPr>
-              <a:t>2</a:t>
-            </a:r>
-          </a:p>
-        </p:txBody>
-      </p:sp>
-      <p:sp>
-        <p:nvSpPr>
-          <p:cNvPr id="6" name="Rectangle 5"/>
+      </p:pic>
+    </p:spTree>
+  </p:cSld>
+  <p:clrMapOvr>
+    <a:masterClrMapping/>
+  </p:clrMapOvr>
+</p:sld>
+</file>
+
+<file path=ppt/slides/slide5.xml><?xml version="1.0" encoding="utf-8"?>
+<p:sld xmlns:a="http://schemas.openxmlformats.org/drawingml/2006/main" xmlns:p="http://schemas.openxmlformats.org/presentationml/2006/main" xmlns:r="http://schemas.openxmlformats.org/officeDocument/2006/relationships">
+  <p:cSld>
+    <p:spTree>
+      <p:nvGrpSpPr>
+        <p:cNvPr id="1" name=""/>
+        <p:cNvGrpSpPr/>
+        <p:nvPr/>
+      </p:nvGrpSpPr>
+      <p:grpSpPr/>
+      <p:sp>
+        <p:nvSpPr>
+          <p:cNvPr id="4" name="Rounded Rectangle 3"/>
           <p:cNvSpPr/>
           <p:nvPr/>
         </p:nvSpPr>
         <p:spPr>
           <a:xfrm>
-            <a:off x="658368" y="1325880"/>
-            <a:ext cx="2926080" cy="36576"/>
+            <a:off x="640080" y="457200"/>
+            <a:ext cx="6208776" cy="841248"/>
           </a:xfrm>
-          <a:prstGeom prst="rect">
+          <a:prstGeom prst="roundRect">
             <a:avLst/>
           </a:prstGeom>
           <a:solidFill>
@@ -3940,30 +4090,174 @@
           </a:p>
         </p:txBody>
       </p:sp>
-      <p:pic>
-        <p:nvPicPr>
-          <p:cNvPr id="7" name="Picture 6" descr="topology.png"/>
-          <p:cNvPicPr>
-            <a:picLocks noChangeAspect="1"/>
-          </p:cNvPicPr>
-          <p:nvPr/>
-        </p:nvPicPr>
-        <p:blipFill>
-          <a:blip r:embed="rId2"/>
-          <a:stretch>
-            <a:fillRect/>
-          </a:stretch>
-        </p:blipFill>
+      <p:sp>
+        <p:nvSpPr>
+          <p:cNvPr id="2" name="Title 1"/>
+          <p:cNvSpPr>
+            <a:spLocks noGrp="1"/>
+          </p:cNvSpPr>
+          <p:nvPr>
+            <p:ph type="title"/>
+          </p:nvPr>
+        </p:nvSpPr>
         <p:spPr>
           <a:xfrm>
-            <a:off x="6400800" y="2560909"/>
-            <a:ext cx="3824935" cy="2467700"/>
+            <a:off x="896112" y="457200"/>
+            <a:ext cx="5751576" cy="841248"/>
           </a:xfrm>
-          <a:prstGeom prst="rect">
-            <a:avLst/>
-          </a:prstGeom>
         </p:spPr>
-      </p:pic>
+        <p:txBody>
+          <a:bodyPr wrap="square" anchor="ctr"/>
+          <a:lstStyle/>
+          <a:p>
+            <a:pPr algn="l"/>
+            <a:r>
+              <a:rPr b="1" sz="1900">
+                <a:solidFill>
+                  <a:srgbClr val="FFFFFF"/>
+                </a:solidFill>
+                <a:latin typeface="Corbel"/>
+              </a:rPr>
+              <a:t>Hardest part: one Flask app, two front doors</a:t>
+            </a:r>
+          </a:p>
+        </p:txBody>
+      </p:sp>
+      <p:sp>
+        <p:nvSpPr>
+          <p:cNvPr id="3" name="Content Placeholder 2"/>
+          <p:cNvSpPr>
+            <a:spLocks noGrp="1"/>
+          </p:cNvSpPr>
+          <p:nvPr>
+            <p:ph idx="1"/>
+          </p:nvPr>
+        </p:nvSpPr>
+        <p:spPr>
+          <a:xfrm>
+            <a:off x="658368" y="1600200"/>
+            <a:ext cx="10972800" cy="4663440"/>
+          </a:xfrm>
+        </p:spPr>
+        <p:txBody>
+          <a:bodyPr wrap="square">
+            <a:normAutofit/>
+          </a:bodyPr>
+          <a:lstStyle/>
+          <a:p>
+            <a:pPr>
+              <a:spcAft>
+                <a:spcPts val="900"/>
+              </a:spcAft>
+            </a:pPr>
+            <a:r>
+              <a:rPr sz="1700" b="1">
+                <a:solidFill>
+                  <a:srgbClr val="17924F"/>
+                </a:solidFill>
+                <a:latin typeface="Calibri"/>
+              </a:rPr>
+              <a:t>The problem:</a:t>
+            </a:r>
+          </a:p>
+          <a:p>
+            <a:pPr lvl="1">
+              <a:spcAft>
+                <a:spcPts val="900"/>
+              </a:spcAft>
+            </a:pPr>
+            <a:r>
+              <a:rPr sz="1500" b="0">
+                <a:solidFill>
+                  <a:srgbClr val="232A26"/>
+                </a:solidFill>
+                <a:latin typeface="Calibri"/>
+              </a:rPr>
+              <a:t>The dashboard is a Flask application, but API Gateway invokes a Lambda with a proxy event, not an HTTP request, so the same code had to answer in both worlds.</a:t>
+            </a:r>
+          </a:p>
+          <a:p>
+            <a:pPr>
+              <a:spcAft>
+                <a:spcPts val="900"/>
+              </a:spcAft>
+            </a:pPr>
+            <a:r>
+              <a:rPr sz="1700" b="1">
+                <a:solidFill>
+                  <a:srgbClr val="17924F"/>
+                </a:solidFill>
+                <a:latin typeface="Calibri"/>
+              </a:rPr>
+              <a:t>Why it was hard:</a:t>
+            </a:r>
+          </a:p>
+          <a:p>
+            <a:pPr lvl="1">
+              <a:spcAft>
+                <a:spcPts val="900"/>
+              </a:spcAft>
+            </a:pPr>
+            <a:r>
+              <a:rPr sz="1500" b="0">
+                <a:solidFill>
+                  <a:srgbClr val="232A26"/>
+                </a:solidFill>
+                <a:latin typeface="Calibri"/>
+              </a:rPr>
+              <a:t>Re-declaring every route for Lambda would drift from the local server over time, and a third-party adapter would add a dependency to maintain.</a:t>
+            </a:r>
+          </a:p>
+          <a:p>
+            <a:pPr>
+              <a:spcAft>
+                <a:spcPts val="900"/>
+              </a:spcAft>
+            </a:pPr>
+            <a:r>
+              <a:rPr sz="1700" b="1">
+                <a:solidFill>
+                  <a:srgbClr val="17924F"/>
+                </a:solidFill>
+                <a:latin typeface="Calibri"/>
+              </a:rPr>
+              <a:t>How it was solved:</a:t>
+            </a:r>
+          </a:p>
+          <a:p>
+            <a:pPr lvl="1">
+              <a:spcAft>
+                <a:spcPts val="900"/>
+              </a:spcAft>
+            </a:pPr>
+            <a:r>
+              <a:rPr sz="1500" b="0">
+                <a:solidFill>
+                  <a:srgbClr val="232A26"/>
+                </a:solidFill>
+                <a:latin typeface="Calibri"/>
+              </a:rPr>
+              <a:t>A small hand-rolled bridge turns the API Gateway proxy event into a standard Python web-server environment and invokes the existing Flask app unchanged, with a cross-origin header on every response.</a:t>
+            </a:r>
+          </a:p>
+          <a:p>
+            <a:pPr>
+              <a:spcAft>
+                <a:spcPts val="900"/>
+              </a:spcAft>
+            </a:pPr>
+            <a:r>
+              <a:rPr sz="1700" b="1">
+                <a:solidFill>
+                  <a:srgbClr val="17924F"/>
+                </a:solidFill>
+                <a:latin typeface="Calibri"/>
+              </a:rPr>
+              <a:t>A pre-deployment audit also confirmed the recurring pitfalls, paginated counting, batched publishing and credential handling, were already correct, so no fix was needed there.</a:t>
+            </a:r>
+          </a:p>
+        </p:txBody>
+      </p:sp>
     </p:spTree>
   </p:cSld>
   <p:clrMapOvr>
@@ -3972,7 +4266,7 @@
 </p:sld>
 </file>
 
-<file path=ppt/slides/slide4.xml><?xml version="1.0" encoding="utf-8"?>
+<file path=ppt/slides/slide6.xml><?xml version="1.0" encoding="utf-8"?>
 <p:sld xmlns:a="http://schemas.openxmlformats.org/drawingml/2006/main" xmlns:p="http://schemas.openxmlformats.org/presentationml/2006/main" xmlns:r="http://schemas.openxmlformats.org/officeDocument/2006/relationships">
   <p:cSld>
     <p:spTree>
@@ -3984,152 +4278,16 @@
       <p:grpSpPr/>
       <p:sp>
         <p:nvSpPr>
-          <p:cNvPr id="2" name="Title 1"/>
-          <p:cNvSpPr>
-            <a:spLocks noGrp="1"/>
-          </p:cNvSpPr>
-          <p:nvPr>
-            <p:ph type="title"/>
-          </p:nvPr>
+          <p:cNvPr id="4" name="Rounded Rectangle 3"/>
+          <p:cNvSpPr/>
+          <p:nvPr/>
         </p:nvSpPr>
         <p:spPr>
           <a:xfrm>
             <a:off x="640080" y="457200"/>
-            <a:ext cx="9311335" cy="868680"/>
+            <a:ext cx="4206240" cy="841248"/>
           </a:xfrm>
-        </p:spPr>
-        <p:txBody>
-          <a:bodyPr wrap="square" anchor="t"/>
-          <a:lstStyle/>
-          <a:p>
-            <a:pPr algn="l"/>
-            <a:r>
-              <a:rPr b="1" sz="2700">
-                <a:solidFill>
-                  <a:srgbClr val="17924F"/>
-                </a:solidFill>
-                <a:latin typeface="Corbel"/>
-              </a:rPr>
-              <a:t>Live on AWS: demonstration highlights</a:t>
-            </a:r>
-          </a:p>
-        </p:txBody>
-      </p:sp>
-      <p:sp>
-        <p:nvSpPr>
-          <p:cNvPr id="3" name="Content Placeholder 2"/>
-          <p:cNvSpPr>
-            <a:spLocks noGrp="1"/>
-          </p:cNvSpPr>
-          <p:nvPr>
-            <p:ph idx="1"/>
-          </p:nvPr>
-        </p:nvSpPr>
-        <p:spPr>
-          <a:xfrm>
-            <a:off x="658368" y="1508760"/>
-            <a:ext cx="5577840" cy="4754880"/>
-          </a:xfrm>
-        </p:spPr>
-        <p:txBody>
-          <a:bodyPr wrap="square">
-            <a:normAutofit/>
-          </a:bodyPr>
-          <a:lstStyle/>
-          <a:p>
-            <a:pPr>
-              <a:spcAft>
-                <a:spcPts val="800"/>
-              </a:spcAft>
-            </a:pPr>
-            <a:r>
-              <a:rPr sz="1500" b="0">
-                <a:solidFill>
-                  <a:srgbClr val="232A26"/>
-                </a:solidFill>
-                <a:latin typeface="Calibri"/>
-              </a:rPr>
-              <a:t>The deployed dashboard, served from Amazon S3 and calling the API through Amazon API Gateway.</a:t>
-            </a:r>
-          </a:p>
-          <a:p>
-            <a:pPr>
-              <a:spcAft>
-                <a:spcPts val="800"/>
-              </a:spcAft>
-            </a:pPr>
-            <a:r>
-              <a:rPr sz="1500" b="0">
-                <a:solidFill>
-                  <a:srgbClr val="232A26"/>
-                </a:solidFill>
-                <a:latin typeface="Calibri"/>
-              </a:rPr>
-              <a:t>Four of four pipeline health checks green on the live account, with the freshest reading a few seconds old.</a:t>
-            </a:r>
-          </a:p>
-          <a:p>
-            <a:pPr>
-              <a:spcAft>
-                <a:spcPts val="800"/>
-              </a:spcAft>
-            </a:pPr>
-            <a:r>
-              <a:rPr sz="1500" b="0">
-                <a:solidFill>
-                  <a:srgbClr val="232A26"/>
-                </a:solidFill>
-                <a:latin typeface="Calibri"/>
-              </a:rPr>
-              <a:t>121 automated tests pass across the sensor, fog, processor and dashboard modules.</a:t>
-            </a:r>
-          </a:p>
-          <a:p>
-            <a:pPr>
-              <a:spcAft>
-                <a:spcPts val="800"/>
-              </a:spcAft>
-            </a:pPr>
-            <a:r>
-              <a:rPr sz="1500" b="0">
-                <a:solidFill>
-                  <a:srgbClr val="232A26"/>
-                </a:solidFill>
-                <a:latin typeface="Calibri"/>
-              </a:rPr>
-              <a:t>Stored records climbed from 26 to 289 across the verification window, confirming genuinely live data.</a:t>
-            </a:r>
-          </a:p>
-          <a:p>
-            <a:pPr>
-              <a:spcAft>
-                <a:spcPts val="800"/>
-              </a:spcAft>
-            </a:pPr>
-            <a:r>
-              <a:rPr sz="1500" b="1">
-                <a:solidFill>
-                  <a:srgbClr val="17924F"/>
-                </a:solidFill>
-                <a:latin typeface="Calibri"/>
-              </a:rPr>
-              <a:t>Two safety alerts firing live on hub-1: overheat risk and grid strain, both raised at the fog node.</a:t>
-            </a:r>
-          </a:p>
-        </p:txBody>
-      </p:sp>
-      <p:sp>
-        <p:nvSpPr>
-          <p:cNvPr id="4" name="Rectangle 3"/>
-          <p:cNvSpPr/>
-          <p:nvPr/>
-        </p:nvSpPr>
-        <p:spPr>
-          <a:xfrm>
-            <a:off x="11140135" y="0"/>
-            <a:ext cx="1051560" cy="6858000"/>
-          </a:xfrm>
-          <a:prstGeom prst="rect">
+          <a:prstGeom prst="roundRect">
             <a:avLst/>
           </a:prstGeom>
           <a:solidFill>
@@ -4164,172 +4322,51 @@
       </p:sp>
       <p:sp>
         <p:nvSpPr>
-          <p:cNvPr id="5" name="TextBox 4"/>
-          <p:cNvSpPr txBox="1"/>
-          <p:nvPr/>
+          <p:cNvPr id="2" name="Title 1"/>
+          <p:cNvSpPr>
+            <a:spLocks noGrp="1"/>
+          </p:cNvSpPr>
+          <p:nvPr>
+            <p:ph type="title"/>
+          </p:nvPr>
         </p:nvSpPr>
         <p:spPr>
           <a:xfrm>
-            <a:off x="11140135" y="320040"/>
-            <a:ext cx="1051560" cy="914400"/>
+            <a:off x="896112" y="457200"/>
+            <a:ext cx="3749039" cy="841248"/>
           </a:xfrm>
-          <a:prstGeom prst="rect">
-            <a:avLst/>
-          </a:prstGeom>
-          <a:noFill/>
         </p:spPr>
         <p:txBody>
-          <a:bodyPr wrap="square" anchor="t">
-            <a:spAutoFit/>
-          </a:bodyPr>
-          <a:lstStyle/>
-          <a:p>
-            <a:pPr algn="ctr"/>
-            <a:r>
-              <a:rPr sz="2600" b="1" i="0">
+          <a:bodyPr wrap="square" anchor="ctr"/>
+          <a:lstStyle/>
+          <a:p>
+            <a:pPr algn="l"/>
+            <a:r>
+              <a:rPr b="1" sz="2200">
                 <a:solidFill>
                   <a:srgbClr val="FFFFFF"/>
                 </a:solidFill>
                 <a:latin typeface="Corbel"/>
               </a:rPr>
-              <a:t>3</a:t>
-            </a:r>
-          </a:p>
-        </p:txBody>
-      </p:sp>
-      <p:sp>
-        <p:nvSpPr>
-          <p:cNvPr id="6" name="Rectangle 5"/>
-          <p:cNvSpPr/>
-          <p:nvPr/>
+              <a:t>What this project shows</a:t>
+            </a:r>
+          </a:p>
+        </p:txBody>
+      </p:sp>
+      <p:sp>
+        <p:nvSpPr>
+          <p:cNvPr id="3" name="Content Placeholder 2"/>
+          <p:cNvSpPr>
+            <a:spLocks noGrp="1"/>
+          </p:cNvSpPr>
+          <p:nvPr>
+            <p:ph idx="1"/>
+          </p:nvPr>
         </p:nvSpPr>
         <p:spPr>
           <a:xfrm>
-            <a:off x="658368" y="1325880"/>
-            <a:ext cx="2926080" cy="36576"/>
-          </a:xfrm>
-          <a:prstGeom prst="rect">
-            <a:avLst/>
-          </a:prstGeom>
-          <a:solidFill>
-            <a:srgbClr val="17924F"/>
-          </a:solidFill>
-          <a:ln>
-            <a:noFill/>
-          </a:ln>
-          <a:effectLst/>
-        </p:spPr>
-        <p:style>
-          <a:lnRef idx="1">
-            <a:schemeClr val="accent1"/>
-          </a:lnRef>
-          <a:fillRef idx="3">
-            <a:schemeClr val="accent1"/>
-          </a:fillRef>
-          <a:effectRef idx="2">
-            <a:schemeClr val="accent1"/>
-          </a:effectRef>
-          <a:fontRef idx="minor">
-            <a:schemeClr val="lt1"/>
-          </a:fontRef>
-        </p:style>
-        <p:txBody>
-          <a:bodyPr rtlCol="0" anchor="ctr"/>
-          <a:lstStyle/>
-          <a:p>
-            <a:pPr algn="ctr"/>
-          </a:p>
-        </p:txBody>
-      </p:sp>
-      <p:pic>
-        <p:nvPicPr>
-          <p:cNvPr id="7" name="Picture 6" descr="dashboard.png"/>
-          <p:cNvPicPr>
-            <a:picLocks noChangeAspect="1"/>
-          </p:cNvPicPr>
-          <p:nvPr/>
-        </p:nvPicPr>
-        <p:blipFill>
-          <a:blip r:embed="rId2"/>
-          <a:stretch>
-            <a:fillRect/>
-          </a:stretch>
-        </p:blipFill>
-        <p:spPr>
-          <a:xfrm>
-            <a:off x="6400800" y="2182823"/>
-            <a:ext cx="3824935" cy="3223873"/>
-          </a:xfrm>
-          <a:prstGeom prst="rect">
-            <a:avLst/>
-          </a:prstGeom>
-        </p:spPr>
-      </p:pic>
-    </p:spTree>
-  </p:cSld>
-  <p:clrMapOvr>
-    <a:masterClrMapping/>
-  </p:clrMapOvr>
-</p:sld>
-</file>
-
-<file path=ppt/slides/slide5.xml><?xml version="1.0" encoding="utf-8"?>
-<p:sld xmlns:a="http://schemas.openxmlformats.org/drawingml/2006/main" xmlns:p="http://schemas.openxmlformats.org/presentationml/2006/main" xmlns:r="http://schemas.openxmlformats.org/officeDocument/2006/relationships">
-  <p:cSld>
-    <p:spTree>
-      <p:nvGrpSpPr>
-        <p:cNvPr id="1" name=""/>
-        <p:cNvGrpSpPr/>
-        <p:nvPr/>
-      </p:nvGrpSpPr>
-      <p:grpSpPr/>
-      <p:sp>
-        <p:nvSpPr>
-          <p:cNvPr id="2" name="Title 1"/>
-          <p:cNvSpPr>
-            <a:spLocks noGrp="1"/>
-          </p:cNvSpPr>
-          <p:nvPr>
-            <p:ph type="title"/>
-          </p:nvPr>
-        </p:nvSpPr>
-        <p:spPr>
-          <a:xfrm>
-            <a:off x="640080" y="457200"/>
-            <a:ext cx="9311335" cy="868680"/>
-          </a:xfrm>
-        </p:spPr>
-        <p:txBody>
-          <a:bodyPr wrap="square" anchor="t"/>
-          <a:lstStyle/>
-          <a:p>
-            <a:pPr algn="l"/>
-            <a:r>
-              <a:rPr b="1" sz="2400">
-                <a:solidFill>
-                  <a:srgbClr val="17924F"/>
-                </a:solidFill>
-                <a:latin typeface="Corbel"/>
-              </a:rPr>
-              <a:t>Hardest part: one Flask app, two front doors</a:t>
-            </a:r>
-          </a:p>
-        </p:txBody>
-      </p:sp>
-      <p:sp>
-        <p:nvSpPr>
-          <p:cNvPr id="3" name="Content Placeholder 2"/>
-          <p:cNvSpPr>
-            <a:spLocks noGrp="1"/>
-          </p:cNvSpPr>
-          <p:nvPr>
-            <p:ph idx="1"/>
-          </p:nvPr>
-        </p:nvSpPr>
-        <p:spPr>
-          <a:xfrm>
-            <a:off x="658368" y="1508760"/>
-            <a:ext cx="9402775" cy="4846320"/>
+            <a:off x="658368" y="1600200"/>
+            <a:ext cx="10972800" cy="4663440"/>
           </a:xfrm>
         </p:spPr>
         <p:txBody>
@@ -4344,29 +4381,13 @@
               </a:spcAft>
             </a:pPr>
             <a:r>
-              <a:rPr sz="1700" b="1">
-                <a:solidFill>
-                  <a:srgbClr val="17924F"/>
+              <a:rPr sz="1700" b="0">
+                <a:solidFill>
+                  <a:srgbClr val="232A26"/>
                 </a:solidFill>
                 <a:latin typeface="Calibri"/>
               </a:rPr>
-              <a:t>The problem:</a:t>
-            </a:r>
-          </a:p>
-          <a:p>
-            <a:pPr lvl="1">
-              <a:spcAft>
-                <a:spcPts val="900"/>
-              </a:spcAft>
-            </a:pPr>
-            <a:r>
-              <a:rPr sz="1500" b="0">
-                <a:solidFill>
-                  <a:srgbClr val="232A26"/>
-                </a:solidFill>
-                <a:latin typeface="Calibri"/>
-              </a:rPr>
-              <a:t>The dashboard is a Flask application, but API Gateway invokes a Lambda with a proxy event, not an HTTP request, so the same code had to answer in both worlds.</a:t>
+              <a:t>Decide at the edge: the fog node turns raw 2-to-5-second readings into one windowed summary and an instant alert, right next to the hardware.</a:t>
             </a:r>
           </a:p>
           <a:p>
@@ -4376,29 +4397,13 @@
               </a:spcAft>
             </a:pPr>
             <a:r>
-              <a:rPr sz="1700" b="1">
-                <a:solidFill>
-                  <a:srgbClr val="17924F"/>
+              <a:rPr sz="1700" b="0">
+                <a:solidFill>
+                  <a:srgbClr val="232A26"/>
                 </a:solidFill>
                 <a:latin typeface="Calibri"/>
               </a:rPr>
-              <a:t>Why it was hard:</a:t>
-            </a:r>
-          </a:p>
-          <a:p>
-            <a:pPr lvl="1">
-              <a:spcAft>
-                <a:spcPts val="900"/>
-              </a:spcAft>
-            </a:pPr>
-            <a:r>
-              <a:rPr sz="1500" b="0">
-                <a:solidFill>
-                  <a:srgbClr val="232A26"/>
-                </a:solidFill>
-                <a:latin typeface="Calibri"/>
-              </a:rPr>
-              <a:t>Re-declaring every route for Lambda would drift from the local server over time, and a third-party adapter would add a dependency to maintain.</a:t>
+              <a:t>Let the cloud absorb the load: a managed queue and serverless functions scale per request and cost nothing while idle.</a:t>
             </a:r>
           </a:p>
           <a:p>
@@ -4414,23 +4419,7 @@
                 </a:solidFill>
                 <a:latin typeface="Calibri"/>
               </a:rPr>
-              <a:t>How it was solved:</a:t>
-            </a:r>
-          </a:p>
-          <a:p>
-            <a:pPr lvl="1">
-              <a:spcAft>
-                <a:spcPts val="900"/>
-              </a:spcAft>
-            </a:pPr>
-            <a:r>
-              <a:rPr sz="1500" b="0">
-                <a:solidFill>
-                  <a:srgbClr val="232A26"/>
-                </a:solidFill>
-                <a:latin typeface="Calibri"/>
-              </a:rPr>
-              <a:t>A small hand-rolled bridge turns the API Gateway proxy event into a standard Python web-server environment and invokes the existing Flask app unchanged, with a cross-origin header on every response.</a:t>
+              <a:t>Trust is tested, not assumed: 121 automated tests and a live end-to-end verification on real AWS stand behind every number on the dashboard.</a:t>
             </a:r>
           </a:p>
           <a:p>
@@ -4440,267 +4429,6 @@
               </a:spcAft>
             </a:pPr>
             <a:r>
-              <a:rPr sz="1700" b="1">
-                <a:solidFill>
-                  <a:srgbClr val="17924F"/>
-                </a:solidFill>
-                <a:latin typeface="Calibri"/>
-              </a:rPr>
-              <a:t>A pre-deployment audit also confirmed the recurring pitfalls, paginated counting, batched publishing and credential handling, were already correct, so no fix was needed there.</a:t>
-            </a:r>
-          </a:p>
-        </p:txBody>
-      </p:sp>
-      <p:sp>
-        <p:nvSpPr>
-          <p:cNvPr id="4" name="Rectangle 3"/>
-          <p:cNvSpPr/>
-          <p:nvPr/>
-        </p:nvSpPr>
-        <p:spPr>
-          <a:xfrm>
-            <a:off x="11140135" y="0"/>
-            <a:ext cx="1051560" cy="6858000"/>
-          </a:xfrm>
-          <a:prstGeom prst="rect">
-            <a:avLst/>
-          </a:prstGeom>
-          <a:solidFill>
-            <a:srgbClr val="17924F"/>
-          </a:solidFill>
-          <a:ln>
-            <a:noFill/>
-          </a:ln>
-          <a:effectLst/>
-        </p:spPr>
-        <p:style>
-          <a:lnRef idx="1">
-            <a:schemeClr val="accent1"/>
-          </a:lnRef>
-          <a:fillRef idx="3">
-            <a:schemeClr val="accent1"/>
-          </a:fillRef>
-          <a:effectRef idx="2">
-            <a:schemeClr val="accent1"/>
-          </a:effectRef>
-          <a:fontRef idx="minor">
-            <a:schemeClr val="lt1"/>
-          </a:fontRef>
-        </p:style>
-        <p:txBody>
-          <a:bodyPr rtlCol="0" anchor="ctr"/>
-          <a:lstStyle/>
-          <a:p>
-            <a:pPr algn="ctr"/>
-          </a:p>
-        </p:txBody>
-      </p:sp>
-      <p:sp>
-        <p:nvSpPr>
-          <p:cNvPr id="5" name="TextBox 4"/>
-          <p:cNvSpPr txBox="1"/>
-          <p:nvPr/>
-        </p:nvSpPr>
-        <p:spPr>
-          <a:xfrm>
-            <a:off x="11140135" y="320040"/>
-            <a:ext cx="1051560" cy="914400"/>
-          </a:xfrm>
-          <a:prstGeom prst="rect">
-            <a:avLst/>
-          </a:prstGeom>
-          <a:noFill/>
-        </p:spPr>
-        <p:txBody>
-          <a:bodyPr wrap="square" anchor="t">
-            <a:spAutoFit/>
-          </a:bodyPr>
-          <a:lstStyle/>
-          <a:p>
-            <a:pPr algn="ctr"/>
-            <a:r>
-              <a:rPr sz="2600" b="1" i="0">
-                <a:solidFill>
-                  <a:srgbClr val="FFFFFF"/>
-                </a:solidFill>
-                <a:latin typeface="Corbel"/>
-              </a:rPr>
-              <a:t>4</a:t>
-            </a:r>
-          </a:p>
-        </p:txBody>
-      </p:sp>
-      <p:sp>
-        <p:nvSpPr>
-          <p:cNvPr id="6" name="Rectangle 5"/>
-          <p:cNvSpPr/>
-          <p:nvPr/>
-        </p:nvSpPr>
-        <p:spPr>
-          <a:xfrm>
-            <a:off x="658368" y="1325880"/>
-            <a:ext cx="2926080" cy="36576"/>
-          </a:xfrm>
-          <a:prstGeom prst="rect">
-            <a:avLst/>
-          </a:prstGeom>
-          <a:solidFill>
-            <a:srgbClr val="17924F"/>
-          </a:solidFill>
-          <a:ln>
-            <a:noFill/>
-          </a:ln>
-          <a:effectLst/>
-        </p:spPr>
-        <p:style>
-          <a:lnRef idx="1">
-            <a:schemeClr val="accent1"/>
-          </a:lnRef>
-          <a:fillRef idx="3">
-            <a:schemeClr val="accent1"/>
-          </a:fillRef>
-          <a:effectRef idx="2">
-            <a:schemeClr val="accent1"/>
-          </a:effectRef>
-          <a:fontRef idx="minor">
-            <a:schemeClr val="lt1"/>
-          </a:fontRef>
-        </p:style>
-        <p:txBody>
-          <a:bodyPr rtlCol="0" anchor="ctr"/>
-          <a:lstStyle/>
-          <a:p>
-            <a:pPr algn="ctr"/>
-          </a:p>
-        </p:txBody>
-      </p:sp>
-    </p:spTree>
-  </p:cSld>
-  <p:clrMapOvr>
-    <a:masterClrMapping/>
-  </p:clrMapOvr>
-</p:sld>
-</file>
-
-<file path=ppt/slides/slide6.xml><?xml version="1.0" encoding="utf-8"?>
-<p:sld xmlns:a="http://schemas.openxmlformats.org/drawingml/2006/main" xmlns:p="http://schemas.openxmlformats.org/presentationml/2006/main" xmlns:r="http://schemas.openxmlformats.org/officeDocument/2006/relationships">
-  <p:cSld>
-    <p:spTree>
-      <p:nvGrpSpPr>
-        <p:cNvPr id="1" name=""/>
-        <p:cNvGrpSpPr/>
-        <p:nvPr/>
-      </p:nvGrpSpPr>
-      <p:grpSpPr/>
-      <p:sp>
-        <p:nvSpPr>
-          <p:cNvPr id="2" name="Title 1"/>
-          <p:cNvSpPr>
-            <a:spLocks noGrp="1"/>
-          </p:cNvSpPr>
-          <p:nvPr>
-            <p:ph type="title"/>
-          </p:nvPr>
-        </p:nvSpPr>
-        <p:spPr>
-          <a:xfrm>
-            <a:off x="640080" y="457200"/>
-            <a:ext cx="9311335" cy="868680"/>
-          </a:xfrm>
-        </p:spPr>
-        <p:txBody>
-          <a:bodyPr wrap="square" anchor="t"/>
-          <a:lstStyle/>
-          <a:p>
-            <a:pPr algn="l"/>
-            <a:r>
-              <a:rPr b="1" sz="2700">
-                <a:solidFill>
-                  <a:srgbClr val="17924F"/>
-                </a:solidFill>
-                <a:latin typeface="Corbel"/>
-              </a:rPr>
-              <a:t>What this project shows</a:t>
-            </a:r>
-          </a:p>
-        </p:txBody>
-      </p:sp>
-      <p:sp>
-        <p:nvSpPr>
-          <p:cNvPr id="3" name="Content Placeholder 2"/>
-          <p:cNvSpPr>
-            <a:spLocks noGrp="1"/>
-          </p:cNvSpPr>
-          <p:nvPr>
-            <p:ph idx="1"/>
-          </p:nvPr>
-        </p:nvSpPr>
-        <p:spPr>
-          <a:xfrm>
-            <a:off x="658368" y="1508760"/>
-            <a:ext cx="9402775" cy="4846320"/>
-          </a:xfrm>
-        </p:spPr>
-        <p:txBody>
-          <a:bodyPr wrap="square">
-            <a:normAutofit/>
-          </a:bodyPr>
-          <a:lstStyle/>
-          <a:p>
-            <a:pPr>
-              <a:spcAft>
-                <a:spcPts val="900"/>
-              </a:spcAft>
-            </a:pPr>
-            <a:r>
-              <a:rPr sz="1700" b="0">
-                <a:solidFill>
-                  <a:srgbClr val="232A26"/>
-                </a:solidFill>
-                <a:latin typeface="Calibri"/>
-              </a:rPr>
-              <a:t>Decide at the edge: the fog node turns raw 2-to-5-second readings into one windowed summary and an instant alert, right next to the hardware.</a:t>
-            </a:r>
-          </a:p>
-          <a:p>
-            <a:pPr>
-              <a:spcAft>
-                <a:spcPts val="900"/>
-              </a:spcAft>
-            </a:pPr>
-            <a:r>
-              <a:rPr sz="1700" b="0">
-                <a:solidFill>
-                  <a:srgbClr val="232A26"/>
-                </a:solidFill>
-                <a:latin typeface="Calibri"/>
-              </a:rPr>
-              <a:t>Let the cloud absorb the load: a managed queue and serverless functions scale per request and cost nothing while idle.</a:t>
-            </a:r>
-          </a:p>
-          <a:p>
-            <a:pPr>
-              <a:spcAft>
-                <a:spcPts val="900"/>
-              </a:spcAft>
-            </a:pPr>
-            <a:r>
-              <a:rPr sz="1700" b="1">
-                <a:solidFill>
-                  <a:srgbClr val="17924F"/>
-                </a:solidFill>
-                <a:latin typeface="Calibri"/>
-              </a:rPr>
-              <a:t>Trust is tested, not assumed: 121 automated tests and a live end-to-end verification on real AWS stand behind every number on the dashboard.</a:t>
-            </a:r>
-          </a:p>
-          <a:p>
-            <a:pPr>
-              <a:spcAft>
-                <a:spcPts val="900"/>
-              </a:spcAft>
-            </a:pPr>
-            <a:r>
               <a:rPr sz="1700" b="0">
                 <a:solidFill>
                   <a:srgbClr val="232A26"/>
@@ -4709,129 +4437,6 @@
               </a:rPr>
               <a:t>Thank you. Questions?</a:t>
             </a:r>
-          </a:p>
-        </p:txBody>
-      </p:sp>
-      <p:sp>
-        <p:nvSpPr>
-          <p:cNvPr id="4" name="Rectangle 3"/>
-          <p:cNvSpPr/>
-          <p:nvPr/>
-        </p:nvSpPr>
-        <p:spPr>
-          <a:xfrm>
-            <a:off x="11140135" y="0"/>
-            <a:ext cx="1051560" cy="6858000"/>
-          </a:xfrm>
-          <a:prstGeom prst="rect">
-            <a:avLst/>
-          </a:prstGeom>
-          <a:solidFill>
-            <a:srgbClr val="17924F"/>
-          </a:solidFill>
-          <a:ln>
-            <a:noFill/>
-          </a:ln>
-          <a:effectLst/>
-        </p:spPr>
-        <p:style>
-          <a:lnRef idx="1">
-            <a:schemeClr val="accent1"/>
-          </a:lnRef>
-          <a:fillRef idx="3">
-            <a:schemeClr val="accent1"/>
-          </a:fillRef>
-          <a:effectRef idx="2">
-            <a:schemeClr val="accent1"/>
-          </a:effectRef>
-          <a:fontRef idx="minor">
-            <a:schemeClr val="lt1"/>
-          </a:fontRef>
-        </p:style>
-        <p:txBody>
-          <a:bodyPr rtlCol="0" anchor="ctr"/>
-          <a:lstStyle/>
-          <a:p>
-            <a:pPr algn="ctr"/>
-          </a:p>
-        </p:txBody>
-      </p:sp>
-      <p:sp>
-        <p:nvSpPr>
-          <p:cNvPr id="5" name="TextBox 4"/>
-          <p:cNvSpPr txBox="1"/>
-          <p:nvPr/>
-        </p:nvSpPr>
-        <p:spPr>
-          <a:xfrm>
-            <a:off x="11140135" y="320040"/>
-            <a:ext cx="1051560" cy="914400"/>
-          </a:xfrm>
-          <a:prstGeom prst="rect">
-            <a:avLst/>
-          </a:prstGeom>
-          <a:noFill/>
-        </p:spPr>
-        <p:txBody>
-          <a:bodyPr wrap="square" anchor="t">
-            <a:spAutoFit/>
-          </a:bodyPr>
-          <a:lstStyle/>
-          <a:p>
-            <a:pPr algn="ctr"/>
-            <a:r>
-              <a:rPr sz="2600" b="1" i="0">
-                <a:solidFill>
-                  <a:srgbClr val="FFFFFF"/>
-                </a:solidFill>
-                <a:latin typeface="Corbel"/>
-              </a:rPr>
-              <a:t>5</a:t>
-            </a:r>
-          </a:p>
-        </p:txBody>
-      </p:sp>
-      <p:sp>
-        <p:nvSpPr>
-          <p:cNvPr id="6" name="Rectangle 5"/>
-          <p:cNvSpPr/>
-          <p:nvPr/>
-        </p:nvSpPr>
-        <p:spPr>
-          <a:xfrm>
-            <a:off x="658368" y="1325880"/>
-            <a:ext cx="2926080" cy="36576"/>
-          </a:xfrm>
-          <a:prstGeom prst="rect">
-            <a:avLst/>
-          </a:prstGeom>
-          <a:solidFill>
-            <a:srgbClr val="17924F"/>
-          </a:solidFill>
-          <a:ln>
-            <a:noFill/>
-          </a:ln>
-          <a:effectLst/>
-        </p:spPr>
-        <p:style>
-          <a:lnRef idx="1">
-            <a:schemeClr val="accent1"/>
-          </a:lnRef>
-          <a:fillRef idx="3">
-            <a:schemeClr val="accent1"/>
-          </a:fillRef>
-          <a:effectRef idx="2">
-            <a:schemeClr val="accent1"/>
-          </a:effectRef>
-          <a:fontRef idx="minor">
-            <a:schemeClr val="lt1"/>
-          </a:fontRef>
-        </p:style>
-        <p:txBody>
-          <a:bodyPr rtlCol="0" anchor="ctr"/>
-          <a:lstStyle/>
-          <a:p>
-            <a:pPr algn="ctr"/>
           </a:p>
         </p:txBody>
       </p:sp>

</xml_diff>